<commit_message>
Added PDF & PPT
</commit_message>
<xml_diff>
--- a/Codebase_Atlas_Pitch_Deck.pptx
+++ b/Codebase_Atlas_Pitch_Deck.pptx
@@ -3974,7 +3974,7 @@
         <p:spPr>
           <a:xfrm>
             <a:off x="0" y="3429000"/>
-            <a:ext cx="12191695" cy="731520"/>
+            <a:ext cx="12191695" cy="329321"/>
           </a:xfrm>
           <a:prstGeom prst="rect">
             <a:avLst/>
@@ -3999,13 +3999,22 @@
               </a:spcAft>
             </a:pPr>
             <a:r>
-              <a:rPr sz="1900" b="0" i="1">
+              <a:rPr lang="en-US" sz="1900" b="0" i="1" dirty="0">
                 <a:solidFill>
                   <a:srgbClr val="22D3EE"/>
                 </a:solidFill>
                 <a:latin typeface="Segoe UI"/>
               </a:rPr>
-              <a:t>Google Maps for any codebase — an AI guide flies you through the code</a:t>
+              <a:t>Navigate Code like Never Before </a:t>
+            </a:r>
+            <a:r>
+              <a:rPr sz="1900" b="0" i="1" dirty="0">
+                <a:solidFill>
+                  <a:srgbClr val="22D3EE"/>
+                </a:solidFill>
+                <a:latin typeface="Segoe UI"/>
+              </a:rPr>
+              <a:t>— an AI guide flies you through the code</a:t>
             </a:r>
           </a:p>
         </p:txBody>

</xml_diff>